<commit_message>
feat: rename project to FoodLink Agent, purge all hackathon references, and update presentation & lean canvas
</commit_message>
<xml_diff>
--- a/Surplus_Router_AI_Solutions_Presentation.pptx
+++ b/Surplus_Router_AI_Solutions_Presentation.pptx
@@ -3195,7 +3195,7 @@
               </a:defRPr>
             </a:pPr>
             <a:r>
-              <a:t>🌱 AWS GOOD NEIGHBOR AGENTS TRACK</a:t>
+              <a:t>🌱 AUTONOMOUS COMMUNITY RESCUE AGENT</a:t>
             </a:r>
           </a:p>
           <a:p>
@@ -3211,7 +3211,7 @@
               </a:defRPr>
             </a:pPr>
             <a:r>
-              <a:t>Surplus Router</a:t>
+              <a:t>FoodLink Agent</a:t>
             </a:r>
           </a:p>
           <a:p>
@@ -3494,7 +3494,7 @@
             </a:r>
             <a:br/>
             <a:r>
-              <a:t>Project: Surplus Router (Autonomous Bedrock AgentCore)</a:t>
+              <a:t>Project: FoodLink Agent (Autonomous Bedrock AgentCore)</a:t>
             </a:r>
             <a:br/>
             <a:r>
@@ -3502,7 +3502,7 @@
             </a:r>
             <a:br/>
             <a:r>
-              <a:t>GitHub: https://github.com/kuldeep-poonia/food-rescue-coordination-agent</a:t>
+              <a:t>GitHub: https://github.com/bhumibisen12/food-rescue-coordination-agent</a:t>
             </a:r>
           </a:p>
         </p:txBody>
@@ -4605,7 +4605,7 @@
               </a:defRPr>
             </a:pPr>
             <a:r>
-              <a:t>Busy chefs and banquet managers trash edible food because existing recovery apps require tedious account signups. Surplus Router issues cryptographic 256-bit tracking secrets for instant, passwordless coordination.</a:t>
+              <a:t>Busy chefs and banquet managers trash edible food because existing recovery apps require tedious account signups. FoodLink Agent issues cryptographic 256-bit tracking secrets for instant, passwordless coordination.</a:t>
             </a:r>
           </a:p>
         </p:txBody>
@@ -5272,7 +5272,7 @@
               </a:defRPr>
             </a:pPr>
             <a:r>
-              <a:t>Standard delivery algorithms only minimize travel distance. Surplus Router introduces a food-perishability decay multiplier into the objective function:</a:t>
+              <a:t>Standard delivery algorithms only minimize travel distance. FoodLink Agent introduces a food-perishability decay multiplier into the objective function:</a:t>
             </a:r>
           </a:p>
           <a:p>
@@ -8808,7 +8808,7 @@
               </a:defRPr>
             </a:pPr>
             <a:r>
-              <a:t>Autonomous AI coordination must never jeopardize donor privacy, shelter dignity, or food safety. Surplus Router combines cryptographic Zero-IDOR isolation with deterministic human-in-the-loop escalation boundaries.</a:t>
+              <a:t>Autonomous AI coordination must never jeopardize donor privacy, shelter dignity, or food safety. FoodLink Agent combines cryptographic Zero-IDOR isolation with deterministic human-in-the-loop escalation boundaries.</a:t>
             </a:r>
           </a:p>
         </p:txBody>

</xml_diff>